<commit_message>
Slides: badged PPTX of sd-02-030
</commit_message>
<xml_diff>
--- a/system-design-101/vi/lessons/sd-02-030/slides/sd-02-030.pptx
+++ b/system-design-101/vi/lessons/sd-02-030/slides/sd-02-030.pptx
@@ -3211,7 +3211,7 @@
         <p:spPr>
           <a:xfrm>
             <a:off x="6515100" y="5581650"/>
-            <a:ext cx="5257800" cy="2857500"/>
+            <a:ext cx="10858500" cy="2857500"/>
           </a:xfrm>
           <a:prstGeom prst="roundRect">
             <a:avLst>
@@ -3231,34 +3231,7 @@
       </p:sp>
       <p:sp>
         <p:nvSpPr>
-          <p:cNvPr id="9" name="Shape 7"/>
-          <p:cNvSpPr/>
-          <p:nvPr/>
-        </p:nvSpPr>
-        <p:spPr>
-          <a:xfrm>
-            <a:off x="12115800" y="5581650"/>
-            <a:ext cx="5257800" cy="2857500"/>
-          </a:xfrm>
-          <a:prstGeom prst="roundRect">
-            <a:avLst>
-              <a:gd name="adj" fmla="val 9333"/>
-            </a:avLst>
-          </a:prstGeom>
-          <a:solidFill>
-            <a:srgbClr val="1E212B"/>
-          </a:solidFill>
-          <a:ln w="28575">
-            <a:solidFill>
-              <a:srgbClr val="9AA0B5"/>
-            </a:solidFill>
-            <a:prstDash val="solid"/>
-          </a:ln>
-        </p:spPr>
-      </p:sp>
-      <p:sp>
-        <p:nvSpPr>
-          <p:cNvPr id="10" name="Text 8"/>
+          <p:cNvPr id="9" name="Text 7"/>
           <p:cNvSpPr/>
           <p:nvPr/>
         </p:nvSpPr>
@@ -3297,7 +3270,7 @@
       </p:sp>
       <p:sp>
         <p:nvSpPr>
-          <p:cNvPr id="11" name="Text 9"/>
+          <p:cNvPr id="10" name="Text 8"/>
           <p:cNvSpPr/>
           <p:nvPr/>
         </p:nvSpPr>
@@ -3383,7 +3356,7 @@
       </p:sp>
       <p:sp>
         <p:nvSpPr>
-          <p:cNvPr id="12" name="Text 10"/>
+          <p:cNvPr id="11" name="Text 9"/>
           <p:cNvSpPr/>
           <p:nvPr/>
         </p:nvSpPr>
@@ -3422,7 +3395,7 @@
       </p:sp>
       <p:sp>
         <p:nvSpPr>
-          <p:cNvPr id="13" name="Text 11"/>
+          <p:cNvPr id="12" name="Text 10"/>
           <p:cNvSpPr/>
           <p:nvPr/>
         </p:nvSpPr>
@@ -3486,7 +3459,7 @@
       </p:sp>
       <p:sp>
         <p:nvSpPr>
-          <p:cNvPr id="14" name="Text 12"/>
+          <p:cNvPr id="13" name="Text 11"/>
           <p:cNvSpPr/>
           <p:nvPr/>
         </p:nvSpPr>
@@ -3525,7 +3498,7 @@
       </p:sp>
       <p:sp>
         <p:nvSpPr>
-          <p:cNvPr id="15" name="Text 13"/>
+          <p:cNvPr id="14" name="Text 12"/>
           <p:cNvSpPr/>
           <p:nvPr/>
         </p:nvSpPr>
@@ -3600,7 +3573,7 @@
       </p:sp>
       <p:sp>
         <p:nvSpPr>
-          <p:cNvPr id="16" name="Text 14"/>
+          <p:cNvPr id="15" name="Text 13"/>
           <p:cNvSpPr/>
           <p:nvPr/>
         </p:nvSpPr>
@@ -3623,7 +3596,7 @@
               <a:buNone/>
             </a:pPr>
             <a:r>
-              <a:rPr lang="en-US" sz="4500" dirty="0" kern="0">
+              <a:rPr lang="en-US" sz="4500" dirty="0" spc="-3" kern="0">
                 <a:solidFill>
                   <a:srgbClr val="F3EEE3"/>
                 </a:solidFill>
@@ -3631,7 +3604,7 @@
                 <a:ea typeface="Bricolage Grotesque ExtraBold" pitchFamily="34" charset="-122"/>
                 <a:cs typeface="Bricolage Grotesque ExtraBold" pitchFamily="34" charset="-120"/>
               </a:rPr>
-              <a:t>ID</a:t>
+              <a:t>ML</a:t>
             </a:r>
             <a:endParaRPr lang="en-US" sz="4500" dirty="0"/>
           </a:p>
@@ -3639,7 +3612,7 @@
       </p:sp>
       <p:sp>
         <p:nvSpPr>
-          <p:cNvPr id="17" name="Text 15"/>
+          <p:cNvPr id="16" name="Text 14"/>
           <p:cNvSpPr/>
           <p:nvPr/>
         </p:nvSpPr>
@@ -3665,7 +3638,7 @@
               <a:buNone/>
             </a:pPr>
             <a:r>
-              <a:rPr lang="en-US" sz="2400" dirty="0" spc="5" kern="0">
+              <a:rPr lang="en-US" sz="2400" dirty="0" spc="-5" kern="0">
                 <a:solidFill>
                   <a:srgbClr val="E4E1D8"/>
                 </a:solidFill>
@@ -3673,10 +3646,10 @@
                 <a:ea typeface="Be Vietnam Pro" pitchFamily="34" charset="-122"/>
                 <a:cs typeface="Be Vietnam Pro" pitchFamily="34" charset="-120"/>
               </a:rPr>
-              <a:t>mã</a:t>
-            </a:r>
-            <a:r>
-              <a:rPr lang="en-US" sz="2400" dirty="0" spc="20" kern="0">
+              <a:t>học</a:t>
+            </a:r>
+            <a:r>
+              <a:rPr lang="en-US" sz="2400" dirty="0" spc="-6" kern="0">
                 <a:solidFill>
                   <a:srgbClr val="E4E1D8"/>
                 </a:solidFill>
@@ -3684,18 +3657,7 @@
                 <a:ea typeface="Be Vietnam Pro" pitchFamily="34" charset="-122"/>
                 <a:cs typeface="Be Vietnam Pro" pitchFamily="34" charset="-120"/>
               </a:rPr>
-              <a:t> định</a:t>
-            </a:r>
-            <a:r>
-              <a:rPr lang="en-US" sz="2400" dirty="0" spc="1" kern="0">
-                <a:solidFill>
-                  <a:srgbClr val="E4E1D8"/>
-                </a:solidFill>
-                <a:latin typeface="Be Vietnam Pro" pitchFamily="34" charset="0"/>
-                <a:ea typeface="Be Vietnam Pro" pitchFamily="34" charset="-122"/>
-                <a:cs typeface="Be Vietnam Pro" pitchFamily="34" charset="-120"/>
-              </a:rPr>
-              <a:t> danh</a:t>
+              <a:t> máy</a:t>
             </a:r>
             <a:endParaRPr lang="en-US" sz="2400" dirty="0"/>
           </a:p>
@@ -3703,14 +3665,14 @@
       </p:sp>
       <p:sp>
         <p:nvSpPr>
-          <p:cNvPr id="18" name="Text 16"/>
+          <p:cNvPr id="17" name="Text 15"/>
           <p:cNvSpPr/>
           <p:nvPr/>
         </p:nvSpPr>
         <p:spPr>
           <a:xfrm>
             <a:off x="6858000" y="5867400"/>
-            <a:ext cx="4572000" cy="762000"/>
+            <a:ext cx="10096500" cy="571500"/>
           </a:xfrm>
           <a:prstGeom prst="rect">
             <a:avLst/>
@@ -3726,7 +3688,7 @@
               <a:buNone/>
             </a:pPr>
             <a:r>
-              <a:rPr lang="en-US" sz="4500" dirty="0" spc="-3" kern="0">
+              <a:rPr lang="en-US" sz="3300" dirty="0" spc="1" kern="0">
                 <a:solidFill>
                   <a:srgbClr val="F3EEE3"/>
                 </a:solidFill>
@@ -3734,91 +3696,10 @@
                 <a:ea typeface="Bricolage Grotesque ExtraBold" pitchFamily="34" charset="-122"/>
                 <a:cs typeface="Bricolage Grotesque ExtraBold" pitchFamily="34" charset="-120"/>
               </a:rPr>
-              <a:t>ML</a:t>
-            </a:r>
-            <a:endParaRPr lang="en-US" sz="4500" dirty="0"/>
-          </a:p>
-        </p:txBody>
-      </p:sp>
-      <p:sp>
-        <p:nvSpPr>
-          <p:cNvPr id="19" name="Text 17"/>
-          <p:cNvSpPr/>
-          <p:nvPr/>
-        </p:nvSpPr>
-        <p:spPr>
-          <a:xfrm>
-            <a:off x="6858000" y="6724650"/>
-            <a:ext cx="4572000" cy="1428750"/>
-          </a:xfrm>
-          <a:prstGeom prst="rect">
-            <a:avLst/>
-          </a:prstGeom>
-          <a:noFill/>
-          <a:ln/>
-        </p:spPr>
-        <p:txBody>
-          <a:bodyPr wrap="square" lIns="0" tIns="9144" rIns="0" bIns="-9144" rtlCol="0" anchor="t"/>
-          <a:lstStyle/>
-          <a:p>
-            <a:pPr algn="l" indent="0" marL="0">
-              <a:lnSpc>
-                <a:spcPts val="3240"/>
-              </a:lnSpc>
-              <a:buNone/>
-            </a:pPr>
-            <a:r>
-              <a:rPr lang="en-US" sz="2400" dirty="0" spc="-5" kern="0">
-                <a:solidFill>
-                  <a:srgbClr val="E4E1D8"/>
-                </a:solidFill>
-                <a:latin typeface="Be Vietnam Pro" pitchFamily="34" charset="0"/>
-                <a:ea typeface="Be Vietnam Pro" pitchFamily="34" charset="-122"/>
-                <a:cs typeface="Be Vietnam Pro" pitchFamily="34" charset="-120"/>
-              </a:rPr>
-              <a:t>học</a:t>
-            </a:r>
-            <a:r>
-              <a:rPr lang="en-US" sz="2400" dirty="0" spc="-6" kern="0">
-                <a:solidFill>
-                  <a:srgbClr val="E4E1D8"/>
-                </a:solidFill>
-                <a:latin typeface="Be Vietnam Pro" pitchFamily="34" charset="0"/>
-                <a:ea typeface="Be Vietnam Pro" pitchFamily="34" charset="-122"/>
-                <a:cs typeface="Be Vietnam Pro" pitchFamily="34" charset="-120"/>
-              </a:rPr>
-              <a:t> máy</a:t>
-            </a:r>
-            <a:endParaRPr lang="en-US" sz="2400" dirty="0"/>
-          </a:p>
-        </p:txBody>
-      </p:sp>
-      <p:sp>
-        <p:nvSpPr>
-          <p:cNvPr id="20" name="Text 18"/>
-          <p:cNvSpPr/>
-          <p:nvPr/>
-        </p:nvSpPr>
-        <p:spPr>
-          <a:xfrm>
-            <a:off x="12458700" y="5867400"/>
-            <a:ext cx="4572000" cy="571500"/>
-          </a:xfrm>
-          <a:prstGeom prst="rect">
-            <a:avLst/>
-          </a:prstGeom>
-          <a:noFill/>
-          <a:ln/>
-        </p:spPr>
-        <p:txBody>
-          <a:bodyPr wrap="square" lIns="0" tIns="0" rIns="0" bIns="0" rtlCol="0" anchor="t"/>
-          <a:lstStyle/>
-          <a:p>
-            <a:pPr algn="l" indent="0" marL="0">
-              <a:buNone/>
-            </a:pPr>
-            <a:r>
-              <a:rPr lang="en-US" sz="3300" dirty="0" spc="1" kern="0">
+              <a:t>Nguồn</a:t>
+            </a:r>
+            <a:r>
+              <a:rPr lang="en-US" sz="3300" dirty="0" spc="6" kern="0">
                 <a:solidFill>
                   <a:srgbClr val="F3EEE3"/>
                 </a:solidFill>
@@ -3826,10 +3707,10 @@
                 <a:ea typeface="Bricolage Grotesque ExtraBold" pitchFamily="34" charset="-122"/>
                 <a:cs typeface="Bricolage Grotesque ExtraBold" pitchFamily="34" charset="-120"/>
               </a:rPr>
-              <a:t>Nguồn</a:t>
-            </a:r>
-            <a:r>
-              <a:rPr lang="en-US" sz="3300" dirty="0" spc="6" kern="0">
+              <a:t> đã</a:t>
+            </a:r>
+            <a:r>
+              <a:rPr lang="en-US" sz="3300" dirty="0" spc="5" kern="0">
                 <a:solidFill>
                   <a:srgbClr val="F3EEE3"/>
                 </a:solidFill>
@@ -3837,17 +3718,6 @@
                 <a:ea typeface="Bricolage Grotesque ExtraBold" pitchFamily="34" charset="-122"/>
                 <a:cs typeface="Bricolage Grotesque ExtraBold" pitchFamily="34" charset="-120"/>
               </a:rPr>
-              <a:t> đã</a:t>
-            </a:r>
-            <a:r>
-              <a:rPr lang="en-US" sz="3300" dirty="0" spc="5" kern="0">
-                <a:solidFill>
-                  <a:srgbClr val="F3EEE3"/>
-                </a:solidFill>
-                <a:latin typeface="Bricolage Grotesque ExtraBold" pitchFamily="34" charset="0"/>
-                <a:ea typeface="Bricolage Grotesque ExtraBold" pitchFamily="34" charset="-122"/>
-                <a:cs typeface="Bricolage Grotesque ExtraBold" pitchFamily="34" charset="-120"/>
-              </a:rPr>
               <a:t> đọc</a:t>
             </a:r>
             <a:endParaRPr lang="en-US" sz="3300" dirty="0"/>
@@ -3856,14 +3726,14 @@
       </p:sp>
       <p:sp>
         <p:nvSpPr>
-          <p:cNvPr id="21" name="Text richtext-1792482072026-929187509"/>
-          <p:cNvSpPr/>
-          <p:nvPr/>
-        </p:nvSpPr>
-        <p:spPr>
-          <a:xfrm>
-            <a:off x="12458700" y="6534150"/>
-            <a:ext cx="4572000" cy="1809750"/>
+          <p:cNvPr id="18" name="Text richtext-1792482072026-929187509"/>
+          <p:cNvSpPr/>
+          <p:nvPr/>
+        </p:nvSpPr>
+        <p:spPr>
+          <a:xfrm>
+            <a:off x="6858000" y="6534150"/>
+            <a:ext cx="10096500" cy="1809750"/>
           </a:xfrm>
           <a:prstGeom prst="rect">
             <a:avLst/>
@@ -4049,7 +3919,7 @@
       </p:sp>
       <p:sp>
         <p:nvSpPr>
-          <p:cNvPr id="22" name="Shape 20"/>
+          <p:cNvPr id="19" name="Shape 17"/>
           <p:cNvSpPr/>
           <p:nvPr/>
         </p:nvSpPr>
@@ -4074,7 +3944,7 @@
       </p:sp>
       <p:sp>
         <p:nvSpPr>
-          <p:cNvPr id="23" name="Shape 21"/>
+          <p:cNvPr id="20" name="Shape 18"/>
           <p:cNvSpPr/>
           <p:nvPr/>
         </p:nvSpPr>
@@ -4099,7 +3969,7 @@
       </p:sp>
       <p:sp>
         <p:nvSpPr>
-          <p:cNvPr id="24" name="Shape 22"/>
+          <p:cNvPr id="21" name="Shape 19"/>
           <p:cNvSpPr/>
           <p:nvPr/>
         </p:nvSpPr>
@@ -4124,7 +3994,7 @@
       </p:sp>
       <p:sp>
         <p:nvSpPr>
-          <p:cNvPr id="25" name="Shape 23"/>
+          <p:cNvPr id="22" name="Shape 20"/>
           <p:cNvSpPr/>
           <p:nvPr/>
         </p:nvSpPr>
@@ -4149,7 +4019,7 @@
       </p:sp>
       <p:sp>
         <p:nvSpPr>
-          <p:cNvPr id="26" name="Shape 24"/>
+          <p:cNvPr id="23" name="Shape 21"/>
           <p:cNvSpPr/>
           <p:nvPr/>
         </p:nvSpPr>
@@ -4174,7 +4044,7 @@
       </p:sp>
       <p:sp>
         <p:nvSpPr>
-          <p:cNvPr id="27" name="Shape 25"/>
+          <p:cNvPr id="24" name="Shape 22"/>
           <p:cNvSpPr/>
           <p:nvPr/>
         </p:nvSpPr>
@@ -4199,7 +4069,7 @@
       </p:sp>
       <p:sp>
         <p:nvSpPr>
-          <p:cNvPr id="28" name="Shape 26"/>
+          <p:cNvPr id="25" name="Shape 23"/>
           <p:cNvSpPr/>
           <p:nvPr/>
         </p:nvSpPr>
@@ -4224,7 +4094,7 @@
       </p:sp>
       <p:sp>
         <p:nvSpPr>
-          <p:cNvPr id="29" name="Shape 27"/>
+          <p:cNvPr id="26" name="Shape 24"/>
           <p:cNvSpPr/>
           <p:nvPr/>
         </p:nvSpPr>
@@ -4249,7 +4119,7 @@
       </p:sp>
       <p:sp>
         <p:nvSpPr>
-          <p:cNvPr id="30" name="Shape 28"/>
+          <p:cNvPr id="27" name="Shape 25"/>
           <p:cNvSpPr/>
           <p:nvPr/>
         </p:nvSpPr>
@@ -4274,7 +4144,7 @@
       </p:sp>
       <p:sp>
         <p:nvSpPr>
-          <p:cNvPr id="31" name="Shape 29"/>
+          <p:cNvPr id="28" name="Shape 26"/>
           <p:cNvSpPr/>
           <p:nvPr/>
         </p:nvSpPr>
@@ -4299,7 +4169,7 @@
       </p:sp>
       <p:sp>
         <p:nvSpPr>
-          <p:cNvPr id="32" name="Text 30"/>
+          <p:cNvPr id="29" name="Text 27"/>
           <p:cNvSpPr/>
           <p:nvPr/>
         </p:nvSpPr>
@@ -4415,7 +4285,7 @@
       </p:sp>
       <p:sp>
         <p:nvSpPr>
-          <p:cNvPr id="33" name="Shape 31"/>
+          <p:cNvPr id="30" name="Shape 28"/>
           <p:cNvSpPr/>
           <p:nvPr/>
         </p:nvSpPr>
@@ -4439,7 +4309,7 @@
       </p:sp>
       <p:pic>
         <p:nvPicPr>
-          <p:cNvPr id="34" name="Moda image moda-export-watermark-40a37b42-3d6c-4b3d-a564-8cf689830456" descr="">    </p:cNvPr>
+          <p:cNvPr id="31" name="Moda image moda-export-watermark-40a37b42-3d6c-4b3d-a564-8cf689830456" descr="">    </p:cNvPr>
           <p:cNvPicPr>
             <a:picLocks noChangeAspect="1"/>
           </p:cNvPicPr>
@@ -4753,6 +4623,39 @@
               <a:t>Hai</a:t>
             </a:r>
             <a:r>
+              <a:rPr lang="en-US" sz="2850" dirty="0" spc="-2" kern="0">
+                <a:solidFill>
+                  <a:srgbClr val="14161C"/>
+                </a:solidFill>
+                <a:latin typeface="Be Vietnam Pro" pitchFamily="34" charset="0"/>
+                <a:ea typeface="Be Vietnam Pro" pitchFamily="34" charset="-122"/>
+                <a:cs typeface="Be Vietnam Pro" pitchFamily="34" charset="-120"/>
+              </a:rPr>
+              <a:t> nhóm</a:t>
+            </a:r>
+            <a:r>
+              <a:rPr lang="en-US" sz="2850" dirty="0" spc="-14" kern="0">
+                <a:solidFill>
+                  <a:srgbClr val="14161C"/>
+                </a:solidFill>
+                <a:latin typeface="Be Vietnam Pro" pitchFamily="34" charset="0"/>
+                <a:ea typeface="Be Vietnam Pro" pitchFamily="34" charset="-122"/>
+                <a:cs typeface="Be Vietnam Pro" pitchFamily="34" charset="-120"/>
+              </a:rPr>
+              <a:t> tài</a:t>
+            </a:r>
+            <a:r>
+              <a:rPr lang="en-US" sz="2850" dirty="0" spc="2" kern="0">
+                <a:solidFill>
+                  <a:srgbClr val="14161C"/>
+                </a:solidFill>
+                <a:latin typeface="Be Vietnam Pro" pitchFamily="34" charset="0"/>
+                <a:ea typeface="Be Vietnam Pro" pitchFamily="34" charset="-122"/>
+                <a:cs typeface="Be Vietnam Pro" pitchFamily="34" charset="-120"/>
+              </a:rPr>
+              <a:t> liệu</a:t>
+            </a:r>
+            <a:r>
               <a:rPr lang="en-US" sz="2850" dirty="0" spc="-1" kern="0">
                 <a:solidFill>
                   <a:srgbClr val="14161C"/>
@@ -4761,18 +4664,29 @@
                 <a:ea typeface="Be Vietnam Pro" pitchFamily="34" charset="-122"/>
                 <a:cs typeface="Be Vietnam Pro" pitchFamily="34" charset="-120"/>
               </a:rPr>
-              <a:t> thứ</a:t>
-            </a:r>
-            <a:r>
-              <a:rPr lang="en-US" sz="2850" dirty="0" spc="12" kern="0">
-                <a:solidFill>
-                  <a:srgbClr val="14161C"/>
-                </a:solidFill>
-                <a:latin typeface="Be Vietnam Pro" pitchFamily="34" charset="0"/>
-                <a:ea typeface="Be Vietnam Pro" pitchFamily="34" charset="-122"/>
-                <a:cs typeface="Be Vietnam Pro" pitchFamily="34" charset="-120"/>
-              </a:rPr>
-              <a:t> đổi:</a:t>
+              <a:t> đặt cạnh</a:t>
+            </a:r>
+            <a:r>
+              <a:rPr lang="en-US" sz="2850" dirty="0" spc="1" kern="0">
+                <a:solidFill>
+                  <a:srgbClr val="14161C"/>
+                </a:solidFill>
+                <a:latin typeface="Be Vietnam Pro" pitchFamily="34" charset="0"/>
+                <a:ea typeface="Be Vietnam Pro" pitchFamily="34" charset="-122"/>
+                <a:cs typeface="Be Vietnam Pro" pitchFamily="34" charset="-120"/>
+              </a:rPr>
+              <a:t> nhau;</a:t>
+            </a:r>
+            <a:r>
+              <a:rPr lang="en-US" sz="2850" dirty="0" spc="-2" kern="0">
+                <a:solidFill>
+                  <a:srgbClr val="14161C"/>
+                </a:solidFill>
+                <a:latin typeface="Be Vietnam Pro" pitchFamily="34" charset="0"/>
+                <a:ea typeface="Be Vietnam Pro" pitchFamily="34" charset="-122"/>
+                <a:cs typeface="Be Vietnam Pro" pitchFamily="34" charset="-120"/>
+              </a:rPr>
+              <a:t> nguồn không</a:t>
             </a:r>
             <a:r>
               <a:rPr lang="en-US" sz="2850" dirty="0" spc="0" kern="0">
@@ -4783,29 +4697,7 @@
                 <a:ea typeface="Be Vietnam Pro" pitchFamily="34" charset="-122"/>
                 <a:cs typeface="Be Vietnam Pro" pitchFamily="34" charset="-120"/>
               </a:rPr>
-              <a:t> cách</a:t>
-            </a:r>
-            <a:r>
-              <a:rPr lang="en-US" sz="2850" dirty="0" spc="2" kern="0">
-                <a:solidFill>
-                  <a:srgbClr val="14161C"/>
-                </a:solidFill>
-                <a:latin typeface="Be Vietnam Pro" pitchFamily="34" charset="0"/>
-                <a:ea typeface="Be Vietnam Pro" pitchFamily="34" charset="-122"/>
-                <a:cs typeface="Be Vietnam Pro" pitchFamily="34" charset="-120"/>
-              </a:rPr>
-              <a:t> chia</a:t>
-            </a:r>
-            <a:r>
-              <a:rPr lang="en-US" sz="2850" dirty="0" spc="-1" kern="0">
-                <a:solidFill>
-                  <a:srgbClr val="14161C"/>
-                </a:solidFill>
-                <a:latin typeface="Be Vietnam Pro" pitchFamily="34" charset="0"/>
-                <a:ea typeface="Be Vietnam Pro" pitchFamily="34" charset="-122"/>
-                <a:cs typeface="Be Vietnam Pro" pitchFamily="34" charset="-120"/>
-              </a:rPr>
-              <a:t> dữ</a:t>
+              <a:t> nói</a:t>
             </a:r>
             <a:r>
               <a:rPr lang="en-US" sz="2850" dirty="0" spc="1" kern="0">
@@ -4816,40 +4708,29 @@
                 <a:ea typeface="Be Vietnam Pro" pitchFamily="34" charset="-122"/>
                 <a:cs typeface="Be Vietnam Pro" pitchFamily="34" charset="-120"/>
               </a:rPr>
-              <a:t> liệu,</a:t>
-            </a:r>
-            <a:r>
-              <a:rPr lang="en-US" sz="2850" dirty="0" spc="-15" kern="0">
-                <a:solidFill>
-                  <a:srgbClr val="14161C"/>
-                </a:solidFill>
-                <a:latin typeface="Be Vietnam Pro" pitchFamily="34" charset="0"/>
-                <a:ea typeface="Be Vietnam Pro" pitchFamily="34" charset="-122"/>
-                <a:cs typeface="Be Vietnam Pro" pitchFamily="34" charset="-120"/>
-              </a:rPr>
-              <a:t> và</a:t>
-            </a:r>
-            <a:r>
-              <a:rPr lang="en-US" sz="2850" dirty="0" spc="-1" kern="0">
-                <a:solidFill>
-                  <a:srgbClr val="14161C"/>
-                </a:solidFill>
-                <a:latin typeface="Be Vietnam Pro" pitchFamily="34" charset="0"/>
-                <a:ea typeface="Be Vietnam Pro" pitchFamily="34" charset="-122"/>
-                <a:cs typeface="Be Vietnam Pro" pitchFamily="34" charset="-120"/>
-              </a:rPr>
-              <a:t> cách chọn</a:t>
-            </a:r>
-            <a:r>
-              <a:rPr lang="en-US" sz="2850" dirty="0" spc="-16" kern="0">
-                <a:solidFill>
-                  <a:srgbClr val="14161C"/>
-                </a:solidFill>
-                <a:latin typeface="Be Vietnam Pro" pitchFamily="34" charset="0"/>
-                <a:ea typeface="Be Vietnam Pro" pitchFamily="34" charset="-122"/>
-                <a:cs typeface="Be Vietnam Pro" pitchFamily="34" charset="-120"/>
-              </a:rPr>
-              <a:t> tweet.</a:t>
+              <a:t> cái nào</a:t>
+            </a:r>
+            <a:r>
+              <a:rPr lang="en-US" sz="2850" dirty="0" spc="-8" kern="0">
+                <a:solidFill>
+                  <a:srgbClr val="14161C"/>
+                </a:solidFill>
+                <a:latin typeface="Be Vietnam Pro" pitchFamily="34" charset="0"/>
+                <a:ea typeface="Be Vietnam Pro" pitchFamily="34" charset="-122"/>
+                <a:cs typeface="Be Vietnam Pro" pitchFamily="34" charset="-120"/>
+              </a:rPr>
+              <a:t> thay</a:t>
+            </a:r>
+            <a:r>
+              <a:rPr lang="en-US" sz="2850" dirty="0" spc="1" kern="0">
+                <a:solidFill>
+                  <a:srgbClr val="14161C"/>
+                </a:solidFill>
+                <a:latin typeface="Be Vietnam Pro" pitchFamily="34" charset="0"/>
+                <a:ea typeface="Be Vietnam Pro" pitchFamily="34" charset="-122"/>
+                <a:cs typeface="Be Vietnam Pro" pitchFamily="34" charset="-120"/>
+              </a:rPr>
+              <a:t> cái nào.</a:t>
             </a:r>
             <a:endParaRPr lang="en-US" sz="2850" dirty="0"/>
           </a:p>
@@ -6850,7 +6731,7 @@
               <a:buNone/>
             </a:pPr>
             <a:r>
-              <a:rPr lang="en-US" sz="1950" b="1" spc="312" kern="0" dirty="0">
+              <a:rPr lang="en-US" sz="1950" b="1" spc="302" kern="0" dirty="0">
                 <a:solidFill>
                   <a:srgbClr val="E8472B"/>
                 </a:solidFill>
@@ -6858,10 +6739,10 @@
                 <a:ea typeface="Be Vietnam Pro" pitchFamily="34" charset="-122"/>
                 <a:cs typeface="Be Vietnam Pro" pitchFamily="34" charset="-120"/>
               </a:rPr>
-              <a:t>SO</a:t>
-            </a:r>
-            <a:r>
-              <a:rPr lang="en-US" sz="1950" b="1" spc="289" kern="0" dirty="0">
+              <a:t>TÌNH</a:t>
+            </a:r>
+            <a:r>
+              <a:rPr lang="en-US" sz="1950" b="1" spc="300" kern="0" dirty="0">
                 <a:solidFill>
                   <a:srgbClr val="E8472B"/>
                 </a:solidFill>
@@ -6869,10 +6750,10 @@
                 <a:ea typeface="Be Vietnam Pro" pitchFamily="34" charset="-122"/>
                 <a:cs typeface="Be Vietnam Pro" pitchFamily="34" charset="-120"/>
               </a:rPr>
-              <a:t> SÁNH</a:t>
-            </a:r>
-            <a:r>
-              <a:rPr lang="en-US" sz="1950" b="1" spc="297" kern="0" dirty="0">
+              <a:t> TRẠNG</a:t>
+            </a:r>
+            <a:r>
+              <a:rPr lang="en-US" sz="1950" b="1" spc="296" kern="0" dirty="0">
                 <a:solidFill>
                   <a:srgbClr val="E8472B"/>
                 </a:solidFill>
@@ -6880,10 +6761,10 @@
                 <a:ea typeface="Be Vietnam Pro" pitchFamily="34" charset="-122"/>
                 <a:cs typeface="Be Vietnam Pro" pitchFamily="34" charset="-120"/>
               </a:rPr>
-              <a:t> ·</a:t>
-            </a:r>
-            <a:r>
-              <a:rPr lang="en-US" sz="1950" b="1" spc="301" kern="0" dirty="0">
+              <a:t> THEO</a:t>
+            </a:r>
+            <a:r>
+              <a:rPr lang="en-US" sz="1950" b="1" spc="300" kern="0" dirty="0">
                 <a:solidFill>
                   <a:srgbClr val="E8472B"/>
                 </a:solidFill>
@@ -6891,62 +6772,7 @@
                 <a:ea typeface="Be Vietnam Pro" pitchFamily="34" charset="-122"/>
                 <a:cs typeface="Be Vietnam Pro" pitchFamily="34" charset="-120"/>
               </a:rPr>
-              <a:t> THỜI</a:t>
-            </a:r>
-            <a:r>
-              <a:rPr lang="en-US" sz="1950" b="1" spc="282" kern="0" dirty="0">
-                <a:solidFill>
-                  <a:srgbClr val="E8472B"/>
-                </a:solidFill>
-                <a:latin typeface="Be Vietnam Pro" pitchFamily="34" charset="0"/>
-                <a:ea typeface="Be Vietnam Pro" pitchFamily="34" charset="-122"/>
-                <a:cs typeface="Be Vietnam Pro" pitchFamily="34" charset="-120"/>
-              </a:rPr>
-              <a:t> ĐẦU</a:t>
-            </a:r>
-            <a:r>
-              <a:rPr lang="en-US" sz="1950" b="1" spc="249" kern="0" dirty="0">
-                <a:solidFill>
-                  <a:srgbClr val="E8472B"/>
-                </a:solidFill>
-                <a:latin typeface="Be Vietnam Pro" pitchFamily="34" charset="0"/>
-                <a:ea typeface="Be Vietnam Pro" pitchFamily="34" charset="-122"/>
-                <a:cs typeface="Be Vietnam Pro" pitchFamily="34" charset="-120"/>
-              </a:rPr>
-              <a:t> VÀ</a:t>
-            </a:r>
-            <a:r>
-              <a:rPr lang="en-US" sz="1950" b="1" spc="294" kern="0" dirty="0">
-                <a:solidFill>
-                  <a:srgbClr val="E8472B"/>
-                </a:solidFill>
-                <a:latin typeface="Be Vietnam Pro" pitchFamily="34" charset="0"/>
-                <a:ea typeface="Be Vietnam Pro" pitchFamily="34" charset="-122"/>
-                <a:cs typeface="Be Vietnam Pro" pitchFamily="34" charset="-120"/>
-              </a:rPr>
-              <a:t> BẢN</a:t>
-            </a:r>
-            <a:r>
-              <a:rPr lang="en-US" sz="1950" b="1" spc="297" kern="0" dirty="0">
-                <a:solidFill>
-                  <a:srgbClr val="E8472B"/>
-                </a:solidFill>
-                <a:latin typeface="Be Vietnam Pro" pitchFamily="34" charset="0"/>
-                <a:ea typeface="Be Vietnam Pro" pitchFamily="34" charset="-122"/>
-                <a:cs typeface="Be Vietnam Pro" pitchFamily="34" charset="-120"/>
-              </a:rPr>
-              <a:t> MÃ</a:t>
-            </a:r>
-            <a:r>
-              <a:rPr lang="en-US" sz="1950" b="1" spc="298" kern="0" dirty="0">
-                <a:solidFill>
-                  <a:srgbClr val="E8472B"/>
-                </a:solidFill>
-                <a:latin typeface="Be Vietnam Pro" pitchFamily="34" charset="0"/>
-                <a:ea typeface="Be Vietnam Pro" pitchFamily="34" charset="-122"/>
-                <a:cs typeface="Be Vietnam Pro" pitchFamily="34" charset="-120"/>
-              </a:rPr>
-              <a:t> MỞ</a:t>
+              <a:t> README</a:t>
             </a:r>
             <a:endParaRPr lang="en-US" sz="1950" dirty="0"/>
           </a:p>
@@ -6977,7 +6803,7 @@
               <a:buNone/>
             </a:pPr>
             <a:r>
-              <a:rPr lang="en-US" sz="5400" dirty="0" spc="-3" kern="0">
+              <a:rPr lang="en-US" sz="5400" dirty="0" spc="-15" kern="0">
                 <a:solidFill>
                   <a:srgbClr val="14161C"/>
                 </a:solidFill>
@@ -6985,10 +6811,10 @@
                 <a:ea typeface="Bricolage Grotesque ExtraBold" pitchFamily="34" charset="-122"/>
                 <a:cs typeface="Bricolage Grotesque ExtraBold" pitchFamily="34" charset="-120"/>
               </a:rPr>
-              <a:t>Cái</a:t>
-            </a:r>
-            <a:r>
-              <a:rPr lang="en-US" sz="5400" dirty="0" spc="-4" kern="0">
+              <a:t>Từng</a:t>
+            </a:r>
+            <a:r>
+              <a:rPr lang="en-US" sz="5400" dirty="0" spc="-1" kern="0">
                 <a:solidFill>
                   <a:srgbClr val="14161C"/>
                 </a:solidFill>
@@ -6996,10 +6822,10 @@
                 <a:ea typeface="Bricolage Grotesque ExtraBold" pitchFamily="34" charset="-122"/>
                 <a:cs typeface="Bricolage Grotesque ExtraBold" pitchFamily="34" charset="-120"/>
               </a:rPr>
-              <a:t> cũ</a:t>
-            </a:r>
-            <a:r>
-              <a:rPr lang="en-US" sz="5400" dirty="0" spc="18" kern="0">
+              <a:t> công</a:t>
+            </a:r>
+            <a:r>
+              <a:rPr lang="en-US" sz="5400" dirty="0" spc="-5" kern="0">
                 <a:solidFill>
                   <a:srgbClr val="14161C"/>
                 </a:solidFill>
@@ -7007,7 +6833,7 @@
                 <a:ea typeface="Bricolage Grotesque ExtraBold" pitchFamily="34" charset="-122"/>
                 <a:cs typeface="Bricolage Grotesque ExtraBold" pitchFamily="34" charset="-120"/>
               </a:rPr>
-              <a:t> ngừng,</a:t>
+              <a:t> cụ,</a:t>
             </a:r>
             <a:r>
               <a:rPr lang="en-US" sz="5400" dirty="0" spc="-1" kern="0">
@@ -7018,10 +6844,10 @@
                 <a:ea typeface="Bricolage Grotesque ExtraBold" pitchFamily="34" charset="-122"/>
                 <a:cs typeface="Bricolage Grotesque ExtraBold" pitchFamily="34" charset="-120"/>
               </a:rPr>
-              <a:t> cái</a:t>
-            </a:r>
-            <a:r>
-              <a:rPr lang="en-US" sz="5400" dirty="0" spc="-27" kern="0">
+              <a:t> theo</a:t>
+            </a:r>
+            <a:r>
+              <a:rPr lang="en-US" sz="5400" dirty="0" spc="0" kern="0">
                 <a:solidFill>
                   <a:srgbClr val="14161C"/>
                 </a:solidFill>
@@ -7029,18 +6855,7 @@
                 <a:ea typeface="Bricolage Grotesque ExtraBold" pitchFamily="34" charset="-122"/>
                 <a:cs typeface="Bricolage Grotesque ExtraBold" pitchFamily="34" charset="-120"/>
               </a:rPr>
-              <a:t> mới</a:t>
-            </a:r>
-            <a:r>
-              <a:rPr lang="en-US" sz="5400" dirty="0" spc="-2" kern="0">
-                <a:solidFill>
-                  <a:srgbClr val="14161C"/>
-                </a:solidFill>
-                <a:latin typeface="Bricolage Grotesque ExtraBold" pitchFamily="34" charset="0"/>
-                <a:ea typeface="Bricolage Grotesque ExtraBold" pitchFamily="34" charset="-122"/>
-                <a:cs typeface="Bricolage Grotesque ExtraBold" pitchFamily="34" charset="-120"/>
-              </a:rPr>
-              <a:t> chạy</a:t>
+              <a:t> README</a:t>
             </a:r>
             <a:endParaRPr lang="en-US" sz="5400" dirty="0"/>
           </a:p>
@@ -7401,37 +7216,6 @@
         </p:nvSpPr>
         <p:spPr>
           <a:xfrm>
-            <a:off x="8572500" y="5429250"/>
-            <a:ext cx="1143000" cy="9144"/>
-          </a:xfrm>
-          <a:custGeom>
-            <a:avLst/>
-            <a:gdLst/>
-            <a:ahLst/>
-            <a:cxnLst/>
-            <a:rect l="l" t="t" r="r" b="b"/>
-            <a:pathLst>
-              <a:path w="1143000" h="9144">
-                <a:moveTo>
-                  <a:pt x="0" y="0"/>
-                </a:moveTo>
-                <a:lnTo>
-                  <a:pt x="1143000" y="0"/>
-                </a:lnTo>
-              </a:path>
-            </a:pathLst>
-          </a:custGeom>
-          <a:ln/>
-        </p:spPr>
-      </p:sp>
-      <p:sp>
-        <p:nvSpPr>
-          <p:cNvPr id="8" name="Shape 6"/>
-          <p:cNvSpPr/>
-          <p:nvPr/>
-        </p:nvSpPr>
-        <p:spPr>
-          <a:xfrm>
             <a:off x="9944100" y="2476500"/>
             <a:ext cx="7429500" cy="5905500"/>
           </a:xfrm>
@@ -7453,7 +7237,7 @@
       </p:sp>
       <p:sp>
         <p:nvSpPr>
-          <p:cNvPr id="9" name="Text 7"/>
+          <p:cNvPr id="8" name="Text 6"/>
           <p:cNvSpPr/>
           <p:nvPr/>
         </p:nvSpPr>
@@ -7514,7 +7298,7 @@
       </p:sp>
       <p:sp>
         <p:nvSpPr>
-          <p:cNvPr id="10" name="Text richtext-1792481962040-391454254"/>
+          <p:cNvPr id="9" name="Text richtext-1792481962040-391454254"/>
           <p:cNvSpPr/>
           <p:nvPr/>
         </p:nvSpPr>
@@ -7795,7 +7579,7 @@
       </p:sp>
       <p:sp>
         <p:nvSpPr>
-          <p:cNvPr id="11" name="Shape 9"/>
+          <p:cNvPr id="10" name="Shape 8"/>
           <p:cNvSpPr/>
           <p:nvPr/>
         </p:nvSpPr>
@@ -7820,7 +7604,7 @@
       </p:sp>
       <p:sp>
         <p:nvSpPr>
-          <p:cNvPr id="12" name="Shape 10"/>
+          <p:cNvPr id="11" name="Shape 9"/>
           <p:cNvSpPr/>
           <p:nvPr/>
         </p:nvSpPr>
@@ -7845,7 +7629,7 @@
       </p:sp>
       <p:sp>
         <p:nvSpPr>
-          <p:cNvPr id="13" name="Shape 11"/>
+          <p:cNvPr id="12" name="Shape 10"/>
           <p:cNvSpPr/>
           <p:nvPr/>
         </p:nvSpPr>
@@ -7870,7 +7654,7 @@
       </p:sp>
       <p:sp>
         <p:nvSpPr>
-          <p:cNvPr id="14" name="Shape 12"/>
+          <p:cNvPr id="13" name="Shape 11"/>
           <p:cNvSpPr/>
           <p:nvPr/>
         </p:nvSpPr>
@@ -7895,7 +7679,7 @@
       </p:sp>
       <p:sp>
         <p:nvSpPr>
-          <p:cNvPr id="15" name="Shape 13"/>
+          <p:cNvPr id="14" name="Shape 12"/>
           <p:cNvSpPr/>
           <p:nvPr/>
         </p:nvSpPr>
@@ -7918,7 +7702,7 @@
       </p:sp>
       <p:sp>
         <p:nvSpPr>
-          <p:cNvPr id="16" name="Shape 14"/>
+          <p:cNvPr id="15" name="Shape 13"/>
           <p:cNvSpPr/>
           <p:nvPr/>
         </p:nvSpPr>
@@ -7941,7 +7725,7 @@
       </p:sp>
       <p:sp>
         <p:nvSpPr>
-          <p:cNvPr id="17" name="Shape 15"/>
+          <p:cNvPr id="16" name="Shape 14"/>
           <p:cNvSpPr/>
           <p:nvPr/>
         </p:nvSpPr>
@@ -7964,7 +7748,7 @@
       </p:sp>
       <p:sp>
         <p:nvSpPr>
-          <p:cNvPr id="18" name="Shape 16"/>
+          <p:cNvPr id="17" name="Shape 15"/>
           <p:cNvSpPr/>
           <p:nvPr/>
         </p:nvSpPr>
@@ -7987,7 +7771,7 @@
       </p:sp>
       <p:sp>
         <p:nvSpPr>
-          <p:cNvPr id="19" name="Shape 17"/>
+          <p:cNvPr id="18" name="Shape 16"/>
           <p:cNvSpPr/>
           <p:nvPr/>
         </p:nvSpPr>
@@ -8010,7 +7794,7 @@
       </p:sp>
       <p:sp>
         <p:nvSpPr>
-          <p:cNvPr id="20" name="Shape 18"/>
+          <p:cNvPr id="19" name="Shape 17"/>
           <p:cNvSpPr/>
           <p:nvPr/>
         </p:nvSpPr>
@@ -8033,7 +7817,7 @@
       </p:sp>
       <p:sp>
         <p:nvSpPr>
-          <p:cNvPr id="21" name="Text 19"/>
+          <p:cNvPr id="20" name="Text 18"/>
           <p:cNvSpPr/>
           <p:nvPr/>
         </p:nvSpPr>
@@ -8149,32 +7933,7 @@
       </p:sp>
       <p:sp>
         <p:nvSpPr>
-          <p:cNvPr id="22" name="Connector line-1792481975016-752419308"/>
-          <p:cNvSpPr/>
-          <p:nvPr/>
-        </p:nvSpPr>
-        <p:spPr>
-          <a:xfrm>
-            <a:off x="8572500" y="5429250"/>
-            <a:ext cx="1143000" cy="0"/>
-          </a:xfrm>
-          <a:prstGeom prst="line">
-            <a:avLst/>
-          </a:prstGeom>
-          <a:noFill/>
-          <a:ln w="57150">
-            <a:solidFill>
-              <a:srgbClr val="14161C"/>
-            </a:solidFill>
-            <a:prstDash val="solid"/>
-            <a:headEnd type="none"/>
-            <a:tailEnd type="triangle"/>
-          </a:ln>
-        </p:spPr>
-      </p:sp>
-      <p:sp>
-        <p:nvSpPr>
-          <p:cNvPr id="23" name="Shape 21"/>
+          <p:cNvPr id="21" name="Shape 19"/>
           <p:cNvSpPr/>
           <p:nvPr/>
         </p:nvSpPr>
@@ -8198,7 +7957,7 @@
       </p:sp>
       <p:pic>
         <p:nvPicPr>
-          <p:cNvPr id="24" name="Moda image moda-export-watermark-dc3bcbbd-fc3a-4142-8ae5-301f17048d2e" descr="">    </p:cNvPr>
+          <p:cNvPr id="22" name="Moda image moda-export-watermark-dc3bcbbd-fc3a-4142-8ae5-301f17048d2e" descr="">    </p:cNvPr>
           <p:cNvPicPr>
             <a:picLocks noChangeAspect="1"/>
           </p:cNvPicPr>
@@ -13870,6 +13629,17 @@
               <a:buChar char="•"/>
             </a:pPr>
             <a:r>
+              <a:rPr lang="en-US" sz="2850" dirty="0" spc="-3" kern="0">
+                <a:solidFill>
+                  <a:srgbClr val="14161C"/>
+                </a:solidFill>
+                <a:latin typeface="Be Vietnam Pro" pitchFamily="34" charset="0"/>
+                <a:ea typeface="Be Vietnam Pro" pitchFamily="34" charset="-122"/>
+                <a:cs typeface="Be Vietnam Pro" pitchFamily="34" charset="-120"/>
+              </a:rPr>
+              <a:t>Nên</a:t>
+            </a:r>
+            <a:r>
               <a:rPr lang="en-US" sz="2850" dirty="0" spc="1" kern="0">
                 <a:solidFill>
                   <a:srgbClr val="14161C"/>
@@ -13878,7 +13648,29 @@
                 <a:ea typeface="Be Vietnam Pro" pitchFamily="34" charset="-122"/>
                 <a:cs typeface="Be Vietnam Pro" pitchFamily="34" charset="-120"/>
               </a:rPr>
-              <a:t>Mỗi</a:t>
+              <a:t> phải</a:t>
+            </a:r>
+            <a:r>
+              <a:rPr lang="en-US" sz="2850" dirty="0" spc="-15" kern="0">
+                <a:solidFill>
+                  <a:srgbClr val="14161C"/>
+                </a:solidFill>
+                <a:latin typeface="Be Vietnam Pro" pitchFamily="34" charset="0"/>
+                <a:ea typeface="Be Vietnam Pro" pitchFamily="34" charset="-122"/>
+                <a:cs typeface="Be Vietnam Pro" pitchFamily="34" charset="-120"/>
+              </a:rPr>
+              <a:t> gom</a:t>
+            </a:r>
+            <a:r>
+              <a:rPr lang="en-US" sz="2850" dirty="0" spc="-1" kern="0">
+                <a:solidFill>
+                  <a:srgbClr val="14161C"/>
+                </a:solidFill>
+                <a:latin typeface="Be Vietnam Pro" pitchFamily="34" charset="0"/>
+                <a:ea typeface="Be Vietnam Pro" pitchFamily="34" charset="-122"/>
+                <a:cs typeface="Be Vietnam Pro" pitchFamily="34" charset="-120"/>
+              </a:rPr>
+              <a:t> từ</a:t>
             </a:r>
             <a:r>
               <a:rPr lang="en-US" sz="2850" dirty="0" spc="0" kern="0">
@@ -13889,7 +13681,7 @@
                 <a:ea typeface="Be Vietnam Pro" pitchFamily="34" charset="-122"/>
                 <a:cs typeface="Be Vietnam Pro" pitchFamily="34" charset="-120"/>
               </a:rPr>
-              <a:t> loại</a:t>
+              <a:t> nhiều</a:t>
             </a:r>
             <a:r>
               <a:rPr lang="en-US" sz="2850" dirty="0" spc="-1" kern="0">
@@ -13900,40 +13692,7 @@
                 <a:ea typeface="Be Vietnam Pro" pitchFamily="34" charset="-122"/>
                 <a:cs typeface="Be Vietnam Pro" pitchFamily="34" charset="-120"/>
               </a:rPr>
-              <a:t> cần</a:t>
-            </a:r>
-            <a:r>
-              <a:rPr lang="en-US" sz="2850" dirty="0" spc="-9" kern="0">
-                <a:solidFill>
-                  <a:srgbClr val="14161C"/>
-                </a:solidFill>
-                <a:latin typeface="Be Vietnam Pro" pitchFamily="34" charset="0"/>
-                <a:ea typeface="Be Vietnam Pro" pitchFamily="34" charset="-122"/>
-                <a:cs typeface="Be Vietnam Pro" pitchFamily="34" charset="-120"/>
-              </a:rPr>
-              <a:t> một</a:t>
-            </a:r>
-            <a:r>
-              <a:rPr lang="en-US" sz="2850" dirty="0" spc="-2" kern="0">
-                <a:solidFill>
-                  <a:srgbClr val="14161C"/>
-                </a:solidFill>
-                <a:latin typeface="Be Vietnam Pro" pitchFamily="34" charset="0"/>
-                <a:ea typeface="Be Vietnam Pro" pitchFamily="34" charset="-122"/>
-                <a:cs typeface="Be Vietnam Pro" pitchFamily="34" charset="-120"/>
-              </a:rPr>
-              <a:t> nguồn</a:t>
-            </a:r>
-            <a:r>
-              <a:rPr lang="en-US" sz="2850" dirty="0" spc="9" kern="0">
-                <a:solidFill>
-                  <a:srgbClr val="14161C"/>
-                </a:solidFill>
-                <a:latin typeface="Be Vietnam Pro" pitchFamily="34" charset="0"/>
-                <a:ea typeface="Be Vietnam Pro" pitchFamily="34" charset="-122"/>
-                <a:cs typeface="Be Vietnam Pro" pitchFamily="34" charset="-120"/>
-              </a:rPr>
-              <a:t> riêng.</a:t>
+              <a:t> nguồn.</a:t>
             </a:r>
             <a:endParaRPr lang="en-US" sz="2850" dirty="0"/>
           </a:p>

</xml_diff>